<commit_message>
add startscene and how to play scene
</commit_message>
<xml_diff>
--- a/Assets/Sprite/DeadwaterImage.pptx
+++ b/Assets/Sprite/DeadwaterImage.pptx
@@ -198,7 +198,7 @@
           <a:p>
             <a:fld id="{5B45DF11-532F-40C8-8B4D-09C9B88A97F4}" type="datetimeFigureOut">
               <a:rPr lang="zh-TW" altLang="en-US" smtClean="0"/>
-              <a:t>2026/3/27</a:t>
+              <a:t>2026/3/28</a:t>
             </a:fld>
             <a:endParaRPr lang="zh-TW" altLang="en-US"/>
           </a:p>
@@ -696,7 +696,7 @@
           <a:p>
             <a:fld id="{95DF18DE-5DA6-4497-A6F9-9E38AEF8B1FA}" type="datetimeFigureOut">
               <a:rPr lang="zh-TW" altLang="en-US" smtClean="0"/>
-              <a:t>2026/3/27</a:t>
+              <a:t>2026/3/28</a:t>
             </a:fld>
             <a:endParaRPr lang="zh-TW" altLang="en-US"/>
           </a:p>
@@ -894,7 +894,7 @@
           <a:p>
             <a:fld id="{95DF18DE-5DA6-4497-A6F9-9E38AEF8B1FA}" type="datetimeFigureOut">
               <a:rPr lang="zh-TW" altLang="en-US" smtClean="0"/>
-              <a:t>2026/3/27</a:t>
+              <a:t>2026/3/28</a:t>
             </a:fld>
             <a:endParaRPr lang="zh-TW" altLang="en-US"/>
           </a:p>
@@ -1102,7 +1102,7 @@
           <a:p>
             <a:fld id="{95DF18DE-5DA6-4497-A6F9-9E38AEF8B1FA}" type="datetimeFigureOut">
               <a:rPr lang="zh-TW" altLang="en-US" smtClean="0"/>
-              <a:t>2026/3/27</a:t>
+              <a:t>2026/3/28</a:t>
             </a:fld>
             <a:endParaRPr lang="zh-TW" altLang="en-US"/>
           </a:p>
@@ -1300,7 +1300,7 @@
           <a:p>
             <a:fld id="{95DF18DE-5DA6-4497-A6F9-9E38AEF8B1FA}" type="datetimeFigureOut">
               <a:rPr lang="zh-TW" altLang="en-US" smtClean="0"/>
-              <a:t>2026/3/27</a:t>
+              <a:t>2026/3/28</a:t>
             </a:fld>
             <a:endParaRPr lang="zh-TW" altLang="en-US"/>
           </a:p>
@@ -1575,7 +1575,7 @@
           <a:p>
             <a:fld id="{95DF18DE-5DA6-4497-A6F9-9E38AEF8B1FA}" type="datetimeFigureOut">
               <a:rPr lang="zh-TW" altLang="en-US" smtClean="0"/>
-              <a:t>2026/3/27</a:t>
+              <a:t>2026/3/28</a:t>
             </a:fld>
             <a:endParaRPr lang="zh-TW" altLang="en-US"/>
           </a:p>
@@ -1840,7 +1840,7 @@
           <a:p>
             <a:fld id="{95DF18DE-5DA6-4497-A6F9-9E38AEF8B1FA}" type="datetimeFigureOut">
               <a:rPr lang="zh-TW" altLang="en-US" smtClean="0"/>
-              <a:t>2026/3/27</a:t>
+              <a:t>2026/3/28</a:t>
             </a:fld>
             <a:endParaRPr lang="zh-TW" altLang="en-US"/>
           </a:p>
@@ -2252,7 +2252,7 @@
           <a:p>
             <a:fld id="{95DF18DE-5DA6-4497-A6F9-9E38AEF8B1FA}" type="datetimeFigureOut">
               <a:rPr lang="zh-TW" altLang="en-US" smtClean="0"/>
-              <a:t>2026/3/27</a:t>
+              <a:t>2026/3/28</a:t>
             </a:fld>
             <a:endParaRPr lang="zh-TW" altLang="en-US"/>
           </a:p>
@@ -2393,7 +2393,7 @@
           <a:p>
             <a:fld id="{95DF18DE-5DA6-4497-A6F9-9E38AEF8B1FA}" type="datetimeFigureOut">
               <a:rPr lang="zh-TW" altLang="en-US" smtClean="0"/>
-              <a:t>2026/3/27</a:t>
+              <a:t>2026/3/28</a:t>
             </a:fld>
             <a:endParaRPr lang="zh-TW" altLang="en-US"/>
           </a:p>
@@ -2506,7 +2506,7 @@
           <a:p>
             <a:fld id="{95DF18DE-5DA6-4497-A6F9-9E38AEF8B1FA}" type="datetimeFigureOut">
               <a:rPr lang="zh-TW" altLang="en-US" smtClean="0"/>
-              <a:t>2026/3/27</a:t>
+              <a:t>2026/3/28</a:t>
             </a:fld>
             <a:endParaRPr lang="zh-TW" altLang="en-US"/>
           </a:p>
@@ -2817,7 +2817,7 @@
           <a:p>
             <a:fld id="{95DF18DE-5DA6-4497-A6F9-9E38AEF8B1FA}" type="datetimeFigureOut">
               <a:rPr lang="zh-TW" altLang="en-US" smtClean="0"/>
-              <a:t>2026/3/27</a:t>
+              <a:t>2026/3/28</a:t>
             </a:fld>
             <a:endParaRPr lang="zh-TW" altLang="en-US"/>
           </a:p>
@@ -3105,7 +3105,7 @@
           <a:p>
             <a:fld id="{95DF18DE-5DA6-4497-A6F9-9E38AEF8B1FA}" type="datetimeFigureOut">
               <a:rPr lang="zh-TW" altLang="en-US" smtClean="0"/>
-              <a:t>2026/3/27</a:t>
+              <a:t>2026/3/28</a:t>
             </a:fld>
             <a:endParaRPr lang="zh-TW" altLang="en-US"/>
           </a:p>
@@ -3346,7 +3346,7 @@
           <a:p>
             <a:fld id="{95DF18DE-5DA6-4497-A6F9-9E38AEF8B1FA}" type="datetimeFigureOut">
               <a:rPr lang="zh-TW" altLang="en-US" smtClean="0"/>
-              <a:t>2026/3/27</a:t>
+              <a:t>2026/3/28</a:t>
             </a:fld>
             <a:endParaRPr lang="zh-TW" altLang="en-US"/>
           </a:p>
@@ -3784,13 +3784,15 @@
             <a:avLst/>
           </a:prstGeom>
           <a:solidFill>
-            <a:schemeClr val="accent6">
+            <a:schemeClr val="accent1">
               <a:lumMod val="50000"/>
             </a:schemeClr>
           </a:solidFill>
           <a:ln>
             <a:solidFill>
-              <a:srgbClr val="275317"/>
+              <a:schemeClr val="accent1">
+                <a:lumMod val="50000"/>
+              </a:schemeClr>
             </a:solidFill>
           </a:ln>
         </p:spPr>
@@ -3840,13 +3842,15 @@
             <a:avLst/>
           </a:prstGeom>
           <a:solidFill>
-            <a:schemeClr val="accent6">
+            <a:schemeClr val="accent1">
               <a:lumMod val="50000"/>
             </a:schemeClr>
           </a:solidFill>
           <a:ln>
             <a:solidFill>
-              <a:srgbClr val="275317"/>
+              <a:schemeClr val="accent1">
+                <a:lumMod val="50000"/>
+              </a:schemeClr>
             </a:solidFill>
           </a:ln>
         </p:spPr>
@@ -3896,13 +3900,15 @@
             <a:avLst/>
           </a:prstGeom>
           <a:solidFill>
-            <a:schemeClr val="accent6">
+            <a:schemeClr val="accent1">
               <a:lumMod val="50000"/>
             </a:schemeClr>
           </a:solidFill>
           <a:ln>
             <a:solidFill>
-              <a:srgbClr val="275317"/>
+              <a:schemeClr val="accent1">
+                <a:lumMod val="50000"/>
+              </a:schemeClr>
             </a:solidFill>
           </a:ln>
         </p:spPr>
@@ -3952,13 +3958,15 @@
             <a:avLst/>
           </a:prstGeom>
           <a:solidFill>
-            <a:schemeClr val="accent6">
+            <a:schemeClr val="accent1">
               <a:lumMod val="50000"/>
             </a:schemeClr>
           </a:solidFill>
           <a:ln>
             <a:solidFill>
-              <a:srgbClr val="275317"/>
+              <a:schemeClr val="accent1">
+                <a:lumMod val="50000"/>
+              </a:schemeClr>
             </a:solidFill>
           </a:ln>
         </p:spPr>
@@ -4008,13 +4016,15 @@
             <a:avLst/>
           </a:prstGeom>
           <a:solidFill>
-            <a:schemeClr val="accent6">
+            <a:schemeClr val="accent1">
               <a:lumMod val="50000"/>
             </a:schemeClr>
           </a:solidFill>
           <a:ln>
             <a:solidFill>
-              <a:srgbClr val="275317"/>
+              <a:schemeClr val="accent1">
+                <a:lumMod val="50000"/>
+              </a:schemeClr>
             </a:solidFill>
           </a:ln>
         </p:spPr>
@@ -4064,13 +4074,15 @@
             <a:avLst/>
           </a:prstGeom>
           <a:solidFill>
-            <a:schemeClr val="accent6">
+            <a:schemeClr val="accent1">
               <a:lumMod val="50000"/>
             </a:schemeClr>
           </a:solidFill>
           <a:ln>
             <a:solidFill>
-              <a:srgbClr val="275317"/>
+              <a:schemeClr val="accent1">
+                <a:lumMod val="50000"/>
+              </a:schemeClr>
             </a:solidFill>
           </a:ln>
         </p:spPr>
@@ -4120,13 +4132,15 @@
             <a:avLst/>
           </a:prstGeom>
           <a:solidFill>
-            <a:schemeClr val="accent6">
+            <a:schemeClr val="accent1">
               <a:lumMod val="50000"/>
             </a:schemeClr>
           </a:solidFill>
           <a:ln>
             <a:solidFill>
-              <a:srgbClr val="275317"/>
+              <a:schemeClr val="accent1">
+                <a:lumMod val="50000"/>
+              </a:schemeClr>
             </a:solidFill>
           </a:ln>
         </p:spPr>
@@ -4176,13 +4190,15 @@
             <a:avLst/>
           </a:prstGeom>
           <a:solidFill>
-            <a:schemeClr val="accent6">
+            <a:schemeClr val="accent1">
               <a:lumMod val="50000"/>
             </a:schemeClr>
           </a:solidFill>
           <a:ln>
             <a:solidFill>
-              <a:srgbClr val="275317"/>
+              <a:schemeClr val="accent1">
+                <a:lumMod val="50000"/>
+              </a:schemeClr>
             </a:solidFill>
           </a:ln>
         </p:spPr>
@@ -4285,13 +4301,15 @@
             </a:pathLst>
           </a:custGeom>
           <a:solidFill>
-            <a:schemeClr val="accent6">
+            <a:schemeClr val="accent1">
               <a:lumMod val="50000"/>
             </a:schemeClr>
           </a:solidFill>
           <a:ln>
             <a:solidFill>
-              <a:srgbClr val="275317"/>
+              <a:schemeClr val="accent1">
+                <a:lumMod val="50000"/>
+              </a:schemeClr>
             </a:solidFill>
           </a:ln>
         </p:spPr>
@@ -4341,13 +4359,15 @@
             <a:avLst/>
           </a:prstGeom>
           <a:solidFill>
-            <a:schemeClr val="accent6">
+            <a:schemeClr val="accent1">
               <a:lumMod val="50000"/>
             </a:schemeClr>
           </a:solidFill>
           <a:ln>
             <a:solidFill>
-              <a:srgbClr val="275317"/>
+              <a:schemeClr val="accent1">
+                <a:lumMod val="50000"/>
+              </a:schemeClr>
             </a:solidFill>
           </a:ln>
         </p:spPr>
@@ -4397,13 +4417,15 @@
             <a:avLst/>
           </a:prstGeom>
           <a:solidFill>
-            <a:schemeClr val="accent6">
+            <a:schemeClr val="accent1">
               <a:lumMod val="50000"/>
             </a:schemeClr>
           </a:solidFill>
           <a:ln>
             <a:solidFill>
-              <a:srgbClr val="275317"/>
+              <a:schemeClr val="accent1">
+                <a:lumMod val="50000"/>
+              </a:schemeClr>
             </a:solidFill>
           </a:ln>
         </p:spPr>
@@ -4453,13 +4475,15 @@
             <a:avLst/>
           </a:prstGeom>
           <a:solidFill>
-            <a:schemeClr val="accent6">
+            <a:schemeClr val="accent1">
               <a:lumMod val="50000"/>
             </a:schemeClr>
           </a:solidFill>
           <a:ln>
             <a:solidFill>
-              <a:srgbClr val="275317"/>
+              <a:schemeClr val="accent1">
+                <a:lumMod val="50000"/>
+              </a:schemeClr>
             </a:solidFill>
           </a:ln>
         </p:spPr>
@@ -4509,13 +4533,15 @@
             <a:avLst/>
           </a:prstGeom>
           <a:solidFill>
-            <a:schemeClr val="accent6">
+            <a:schemeClr val="accent1">
               <a:lumMod val="50000"/>
             </a:schemeClr>
           </a:solidFill>
           <a:ln>
             <a:solidFill>
-              <a:srgbClr val="275317"/>
+              <a:schemeClr val="accent1">
+                <a:lumMod val="50000"/>
+              </a:schemeClr>
             </a:solidFill>
           </a:ln>
         </p:spPr>
@@ -4565,13 +4591,15 @@
             <a:avLst/>
           </a:prstGeom>
           <a:solidFill>
-            <a:schemeClr val="accent6">
+            <a:schemeClr val="accent1">
               <a:lumMod val="50000"/>
             </a:schemeClr>
           </a:solidFill>
           <a:ln>
             <a:solidFill>
-              <a:srgbClr val="275317"/>
+              <a:schemeClr val="accent1">
+                <a:lumMod val="50000"/>
+              </a:schemeClr>
             </a:solidFill>
           </a:ln>
         </p:spPr>
@@ -4621,13 +4649,15 @@
             <a:avLst/>
           </a:prstGeom>
           <a:solidFill>
-            <a:schemeClr val="accent6">
+            <a:schemeClr val="accent1">
               <a:lumMod val="50000"/>
             </a:schemeClr>
           </a:solidFill>
           <a:ln>
             <a:solidFill>
-              <a:srgbClr val="275317"/>
+              <a:schemeClr val="accent1">
+                <a:lumMod val="50000"/>
+              </a:schemeClr>
             </a:solidFill>
           </a:ln>
         </p:spPr>
@@ -4677,13 +4707,15 @@
             <a:avLst/>
           </a:prstGeom>
           <a:solidFill>
-            <a:schemeClr val="accent6">
+            <a:schemeClr val="accent1">
               <a:lumMod val="50000"/>
             </a:schemeClr>
           </a:solidFill>
           <a:ln>
             <a:solidFill>
-              <a:srgbClr val="275317"/>
+              <a:schemeClr val="accent1">
+                <a:lumMod val="50000"/>
+              </a:schemeClr>
             </a:solidFill>
           </a:ln>
         </p:spPr>
@@ -4733,13 +4765,15 @@
             <a:avLst/>
           </a:prstGeom>
           <a:solidFill>
-            <a:schemeClr val="accent6">
+            <a:schemeClr val="accent1">
               <a:lumMod val="50000"/>
             </a:schemeClr>
           </a:solidFill>
           <a:ln>
             <a:solidFill>
-              <a:srgbClr val="275317"/>
+              <a:schemeClr val="accent1">
+                <a:lumMod val="50000"/>
+              </a:schemeClr>
             </a:solidFill>
           </a:ln>
         </p:spPr>
@@ -4789,13 +4823,15 @@
             <a:avLst/>
           </a:prstGeom>
           <a:solidFill>
-            <a:schemeClr val="accent6">
+            <a:schemeClr val="accent1">
               <a:lumMod val="50000"/>
             </a:schemeClr>
           </a:solidFill>
           <a:ln>
             <a:solidFill>
-              <a:srgbClr val="275317"/>
+              <a:schemeClr val="accent1">
+                <a:lumMod val="50000"/>
+              </a:schemeClr>
             </a:solidFill>
           </a:ln>
         </p:spPr>
@@ -4845,13 +4881,15 @@
             <a:avLst/>
           </a:prstGeom>
           <a:solidFill>
-            <a:schemeClr val="accent6">
+            <a:schemeClr val="accent1">
               <a:lumMod val="50000"/>
             </a:schemeClr>
           </a:solidFill>
           <a:ln>
             <a:solidFill>
-              <a:srgbClr val="275317"/>
+              <a:schemeClr val="accent1">
+                <a:lumMod val="50000"/>
+              </a:schemeClr>
             </a:solidFill>
           </a:ln>
         </p:spPr>
@@ -4901,13 +4939,15 @@
             <a:avLst/>
           </a:prstGeom>
           <a:solidFill>
-            <a:schemeClr val="accent6">
+            <a:schemeClr val="accent1">
               <a:lumMod val="50000"/>
             </a:schemeClr>
           </a:solidFill>
           <a:ln>
             <a:solidFill>
-              <a:srgbClr val="275317"/>
+              <a:schemeClr val="accent1">
+                <a:lumMod val="50000"/>
+              </a:schemeClr>
             </a:solidFill>
           </a:ln>
         </p:spPr>
@@ -4957,13 +4997,15 @@
             <a:avLst/>
           </a:prstGeom>
           <a:solidFill>
-            <a:schemeClr val="accent6">
+            <a:schemeClr val="accent1">
               <a:lumMod val="50000"/>
             </a:schemeClr>
           </a:solidFill>
           <a:ln>
             <a:solidFill>
-              <a:srgbClr val="275317"/>
+              <a:schemeClr val="accent1">
+                <a:lumMod val="50000"/>
+              </a:schemeClr>
             </a:solidFill>
           </a:ln>
         </p:spPr>
@@ -5013,13 +5055,15 @@
             <a:avLst/>
           </a:prstGeom>
           <a:solidFill>
-            <a:schemeClr val="accent6">
+            <a:schemeClr val="accent1">
               <a:lumMod val="50000"/>
             </a:schemeClr>
           </a:solidFill>
           <a:ln>
             <a:solidFill>
-              <a:srgbClr val="275317"/>
+              <a:schemeClr val="accent1">
+                <a:lumMod val="50000"/>
+              </a:schemeClr>
             </a:solidFill>
           </a:ln>
         </p:spPr>
@@ -5069,13 +5113,15 @@
             <a:avLst/>
           </a:prstGeom>
           <a:solidFill>
-            <a:schemeClr val="accent6">
+            <a:schemeClr val="accent1">
               <a:lumMod val="50000"/>
             </a:schemeClr>
           </a:solidFill>
           <a:ln>
             <a:solidFill>
-              <a:srgbClr val="275317"/>
+              <a:schemeClr val="accent1">
+                <a:lumMod val="50000"/>
+              </a:schemeClr>
             </a:solidFill>
           </a:ln>
         </p:spPr>
@@ -5125,13 +5171,15 @@
             <a:avLst/>
           </a:prstGeom>
           <a:solidFill>
-            <a:schemeClr val="accent6">
+            <a:schemeClr val="accent1">
               <a:lumMod val="50000"/>
             </a:schemeClr>
           </a:solidFill>
           <a:ln>
             <a:solidFill>
-              <a:srgbClr val="275317"/>
+              <a:schemeClr val="accent1">
+                <a:lumMod val="50000"/>
+              </a:schemeClr>
             </a:solidFill>
           </a:ln>
         </p:spPr>
@@ -5242,13 +5290,15 @@
             </a:pathLst>
           </a:custGeom>
           <a:solidFill>
-            <a:schemeClr val="accent6">
+            <a:schemeClr val="accent1">
               <a:lumMod val="50000"/>
             </a:schemeClr>
           </a:solidFill>
           <a:ln>
             <a:solidFill>
-              <a:srgbClr val="275317"/>
+              <a:schemeClr val="accent1">
+                <a:lumMod val="50000"/>
+              </a:schemeClr>
             </a:solidFill>
           </a:ln>
         </p:spPr>
@@ -5298,13 +5348,15 @@
             <a:avLst/>
           </a:prstGeom>
           <a:solidFill>
-            <a:schemeClr val="accent6">
+            <a:schemeClr val="accent1">
               <a:lumMod val="50000"/>
             </a:schemeClr>
           </a:solidFill>
           <a:ln>
             <a:solidFill>
-              <a:srgbClr val="275317"/>
+              <a:schemeClr val="accent1">
+                <a:lumMod val="50000"/>
+              </a:schemeClr>
             </a:solidFill>
           </a:ln>
         </p:spPr>
@@ -5354,13 +5406,15 @@
             <a:avLst/>
           </a:prstGeom>
           <a:solidFill>
-            <a:schemeClr val="accent6">
+            <a:schemeClr val="accent1">
               <a:lumMod val="50000"/>
             </a:schemeClr>
           </a:solidFill>
           <a:ln>
             <a:solidFill>
-              <a:srgbClr val="275317"/>
+              <a:schemeClr val="accent1">
+                <a:lumMod val="50000"/>
+              </a:schemeClr>
             </a:solidFill>
           </a:ln>
         </p:spPr>
@@ -5410,13 +5464,15 @@
             <a:avLst/>
           </a:prstGeom>
           <a:solidFill>
-            <a:schemeClr val="accent6">
+            <a:schemeClr val="accent1">
               <a:lumMod val="50000"/>
             </a:schemeClr>
           </a:solidFill>
           <a:ln>
             <a:solidFill>
-              <a:srgbClr val="275317"/>
+              <a:schemeClr val="accent1">
+                <a:lumMod val="50000"/>
+              </a:schemeClr>
             </a:solidFill>
           </a:ln>
         </p:spPr>
@@ -5466,13 +5522,15 @@
             <a:avLst/>
           </a:prstGeom>
           <a:solidFill>
-            <a:schemeClr val="accent6">
+            <a:schemeClr val="accent1">
               <a:lumMod val="50000"/>
             </a:schemeClr>
           </a:solidFill>
           <a:ln>
             <a:solidFill>
-              <a:srgbClr val="275317"/>
+              <a:schemeClr val="accent1">
+                <a:lumMod val="50000"/>
+              </a:schemeClr>
             </a:solidFill>
           </a:ln>
         </p:spPr>
@@ -5522,13 +5580,15 @@
             <a:avLst/>
           </a:prstGeom>
           <a:solidFill>
-            <a:schemeClr val="accent6">
+            <a:schemeClr val="accent1">
               <a:lumMod val="50000"/>
             </a:schemeClr>
           </a:solidFill>
           <a:ln>
             <a:solidFill>
-              <a:srgbClr val="275317"/>
+              <a:schemeClr val="accent1">
+                <a:lumMod val="50000"/>
+              </a:schemeClr>
             </a:solidFill>
           </a:ln>
         </p:spPr>
@@ -5578,13 +5638,15 @@
             <a:avLst/>
           </a:prstGeom>
           <a:solidFill>
-            <a:schemeClr val="accent6">
+            <a:schemeClr val="accent1">
               <a:lumMod val="50000"/>
             </a:schemeClr>
           </a:solidFill>
           <a:ln>
             <a:solidFill>
-              <a:srgbClr val="275317"/>
+              <a:schemeClr val="accent1">
+                <a:lumMod val="50000"/>
+              </a:schemeClr>
             </a:solidFill>
           </a:ln>
         </p:spPr>
@@ -5634,13 +5696,15 @@
             <a:avLst/>
           </a:prstGeom>
           <a:solidFill>
-            <a:schemeClr val="accent6">
+            <a:schemeClr val="accent1">
               <a:lumMod val="50000"/>
             </a:schemeClr>
           </a:solidFill>
           <a:ln>
             <a:solidFill>
-              <a:srgbClr val="275317"/>
+              <a:schemeClr val="accent1">
+                <a:lumMod val="50000"/>
+              </a:schemeClr>
             </a:solidFill>
           </a:ln>
         </p:spPr>
@@ -5741,13 +5805,15 @@
             </a:pathLst>
           </a:custGeom>
           <a:solidFill>
-            <a:schemeClr val="accent6">
+            <a:schemeClr val="accent1">
               <a:lumMod val="50000"/>
             </a:schemeClr>
           </a:solidFill>
           <a:ln>
             <a:solidFill>
-              <a:srgbClr val="275317"/>
+              <a:schemeClr val="accent1">
+                <a:lumMod val="50000"/>
+              </a:schemeClr>
             </a:solidFill>
           </a:ln>
         </p:spPr>
@@ -5850,13 +5916,15 @@
             </a:pathLst>
           </a:custGeom>
           <a:solidFill>
-            <a:schemeClr val="accent6">
+            <a:schemeClr val="accent1">
               <a:lumMod val="50000"/>
             </a:schemeClr>
           </a:solidFill>
           <a:ln>
             <a:solidFill>
-              <a:srgbClr val="275317"/>
+              <a:schemeClr val="accent1">
+                <a:lumMod val="50000"/>
+              </a:schemeClr>
             </a:solidFill>
           </a:ln>
         </p:spPr>
@@ -5906,13 +5974,15 @@
             <a:avLst/>
           </a:prstGeom>
           <a:solidFill>
-            <a:schemeClr val="accent6">
+            <a:schemeClr val="accent1">
               <a:lumMod val="50000"/>
             </a:schemeClr>
           </a:solidFill>
           <a:ln>
             <a:solidFill>
-              <a:srgbClr val="275317"/>
+              <a:schemeClr val="accent1">
+                <a:lumMod val="50000"/>
+              </a:schemeClr>
             </a:solidFill>
           </a:ln>
         </p:spPr>
@@ -5969,13 +6039,15 @@
             <a:avLst/>
           </a:prstGeom>
           <a:solidFill>
-            <a:schemeClr val="accent6">
+            <a:schemeClr val="accent1">
               <a:lumMod val="50000"/>
             </a:schemeClr>
           </a:solidFill>
           <a:ln>
             <a:solidFill>
-              <a:srgbClr val="275317"/>
+              <a:schemeClr val="accent1">
+                <a:lumMod val="50000"/>
+              </a:schemeClr>
             </a:solidFill>
           </a:ln>
         </p:spPr>
@@ -6032,13 +6104,15 @@
             <a:avLst/>
           </a:prstGeom>
           <a:solidFill>
-            <a:schemeClr val="accent6">
+            <a:schemeClr val="accent1">
               <a:lumMod val="50000"/>
             </a:schemeClr>
           </a:solidFill>
           <a:ln>
             <a:solidFill>
-              <a:srgbClr val="275317"/>
+              <a:schemeClr val="accent1">
+                <a:lumMod val="50000"/>
+              </a:schemeClr>
             </a:solidFill>
           </a:ln>
         </p:spPr>
@@ -6095,13 +6169,15 @@
             <a:avLst/>
           </a:prstGeom>
           <a:solidFill>
-            <a:schemeClr val="accent6">
+            <a:schemeClr val="accent1">
               <a:lumMod val="50000"/>
             </a:schemeClr>
           </a:solidFill>
           <a:ln>
             <a:solidFill>
-              <a:srgbClr val="275317"/>
+              <a:schemeClr val="accent1">
+                <a:lumMod val="50000"/>
+              </a:schemeClr>
             </a:solidFill>
           </a:ln>
         </p:spPr>

</xml_diff>

<commit_message>
finish the majority of the game
</commit_message>
<xml_diff>
--- a/Assets/Sprite/DeadwaterImage.pptx
+++ b/Assets/Sprite/DeadwaterImage.pptx
@@ -5,11 +5,12 @@
     <p:sldMasterId id="2147483648" r:id="rId1"/>
   </p:sldMasterIdLst>
   <p:notesMasterIdLst>
-    <p:notesMasterId r:id="rId4"/>
+    <p:notesMasterId r:id="rId5"/>
   </p:notesMasterIdLst>
   <p:sldIdLst>
     <p:sldId id="256" r:id="rId2"/>
-    <p:sldId id="257" r:id="rId3"/>
+    <p:sldId id="258" r:id="rId3"/>
+    <p:sldId id="257" r:id="rId4"/>
   </p:sldIdLst>
   <p:sldSz cx="12192000" cy="6858000"/>
   <p:notesSz cx="6858000" cy="9144000"/>
@@ -6227,6 +6228,443 @@
 </file>
 
 <file path=ppt/slides/slide2.xml><?xml version="1.0" encoding="utf-8"?>
+<p:sld xmlns:a="http://schemas.openxmlformats.org/drawingml/2006/main" xmlns:r="http://schemas.openxmlformats.org/officeDocument/2006/relationships" xmlns:p="http://schemas.openxmlformats.org/presentationml/2006/main">
+  <p:cSld>
+    <p:spTree>
+      <p:nvGrpSpPr>
+        <p:cNvPr id="1" name=""/>
+        <p:cNvGrpSpPr/>
+        <p:nvPr/>
+      </p:nvGrpSpPr>
+      <p:grpSpPr>
+        <a:xfrm>
+          <a:off x="0" y="0"/>
+          <a:ext cx="0" cy="0"/>
+          <a:chOff x="0" y="0"/>
+          <a:chExt cx="0" cy="0"/>
+        </a:xfrm>
+      </p:grpSpPr>
+      <p:sp>
+        <p:nvSpPr>
+          <p:cNvPr id="4" name="矩形 3">
+            <a:extLst>
+              <a:ext uri="{FF2B5EF4-FFF2-40B4-BE49-F238E27FC236}">
+                <a16:creationId xmlns:a16="http://schemas.microsoft.com/office/drawing/2014/main" id="{AE13F75A-0840-C5DE-E01E-1371A5D38974}"/>
+              </a:ext>
+            </a:extLst>
+          </p:cNvPr>
+          <p:cNvSpPr/>
+          <p:nvPr/>
+        </p:nvSpPr>
+        <p:spPr>
+          <a:xfrm>
+            <a:off x="1814945" y="3082636"/>
+            <a:ext cx="671946" cy="1863437"/>
+          </a:xfrm>
+          <a:prstGeom prst="rect">
+            <a:avLst/>
+          </a:prstGeom>
+          <a:solidFill>
+            <a:schemeClr val="tx2">
+              <a:lumMod val="90000"/>
+              <a:lumOff val="10000"/>
+            </a:schemeClr>
+          </a:solidFill>
+          <a:ln>
+            <a:solidFill>
+              <a:schemeClr val="tx1">
+                <a:lumMod val="95000"/>
+                <a:lumOff val="5000"/>
+              </a:schemeClr>
+            </a:solidFill>
+          </a:ln>
+        </p:spPr>
+        <p:style>
+          <a:lnRef idx="2">
+            <a:schemeClr val="accent1">
+              <a:shade val="15000"/>
+            </a:schemeClr>
+          </a:lnRef>
+          <a:fillRef idx="1">
+            <a:schemeClr val="accent1"/>
+          </a:fillRef>
+          <a:effectRef idx="0">
+            <a:schemeClr val="accent1"/>
+          </a:effectRef>
+          <a:fontRef idx="minor">
+            <a:schemeClr val="lt1"/>
+          </a:fontRef>
+        </p:style>
+        <p:txBody>
+          <a:bodyPr rtlCol="0" anchor="ctr"/>
+          <a:lstStyle/>
+          <a:p>
+            <a:pPr algn="ctr"/>
+            <a:endParaRPr lang="zh-TW" altLang="en-US"/>
+          </a:p>
+        </p:txBody>
+      </p:sp>
+      <p:sp>
+        <p:nvSpPr>
+          <p:cNvPr id="7" name="矩形 6">
+            <a:extLst>
+              <a:ext uri="{FF2B5EF4-FFF2-40B4-BE49-F238E27FC236}">
+                <a16:creationId xmlns:a16="http://schemas.microsoft.com/office/drawing/2014/main" id="{BB5A95A2-8140-D435-7EEB-0927C20471DE}"/>
+              </a:ext>
+            </a:extLst>
+          </p:cNvPr>
+          <p:cNvSpPr/>
+          <p:nvPr/>
+        </p:nvSpPr>
+        <p:spPr>
+          <a:xfrm>
+            <a:off x="3269673" y="3082635"/>
+            <a:ext cx="671946" cy="1863437"/>
+          </a:xfrm>
+          <a:prstGeom prst="rect">
+            <a:avLst/>
+          </a:prstGeom>
+          <a:solidFill>
+            <a:schemeClr val="tx2">
+              <a:lumMod val="90000"/>
+              <a:lumOff val="10000"/>
+            </a:schemeClr>
+          </a:solidFill>
+          <a:ln>
+            <a:solidFill>
+              <a:schemeClr val="tx1">
+                <a:lumMod val="95000"/>
+                <a:lumOff val="5000"/>
+              </a:schemeClr>
+            </a:solidFill>
+          </a:ln>
+        </p:spPr>
+        <p:style>
+          <a:lnRef idx="2">
+            <a:schemeClr val="accent1">
+              <a:shade val="15000"/>
+            </a:schemeClr>
+          </a:lnRef>
+          <a:fillRef idx="1">
+            <a:schemeClr val="accent1"/>
+          </a:fillRef>
+          <a:effectRef idx="0">
+            <a:schemeClr val="accent1"/>
+          </a:effectRef>
+          <a:fontRef idx="minor">
+            <a:schemeClr val="lt1"/>
+          </a:fontRef>
+        </p:style>
+        <p:txBody>
+          <a:bodyPr rtlCol="0" anchor="ctr"/>
+          <a:lstStyle/>
+          <a:p>
+            <a:pPr algn="ctr"/>
+            <a:endParaRPr lang="zh-TW" altLang="en-US"/>
+          </a:p>
+        </p:txBody>
+      </p:sp>
+      <p:sp>
+        <p:nvSpPr>
+          <p:cNvPr id="8" name="矩形 7">
+            <a:extLst>
+              <a:ext uri="{FF2B5EF4-FFF2-40B4-BE49-F238E27FC236}">
+                <a16:creationId xmlns:a16="http://schemas.microsoft.com/office/drawing/2014/main" id="{C64D8479-F146-C394-E3A0-DBC74435801B}"/>
+              </a:ext>
+            </a:extLst>
+          </p:cNvPr>
+          <p:cNvSpPr/>
+          <p:nvPr/>
+        </p:nvSpPr>
+        <p:spPr>
+          <a:xfrm>
+            <a:off x="5666510" y="3082635"/>
+            <a:ext cx="671946" cy="1863437"/>
+          </a:xfrm>
+          <a:prstGeom prst="rect">
+            <a:avLst/>
+          </a:prstGeom>
+          <a:solidFill>
+            <a:srgbClr val="FF0000"/>
+          </a:solidFill>
+          <a:ln>
+            <a:solidFill>
+              <a:schemeClr val="tx2">
+                <a:lumMod val="90000"/>
+                <a:lumOff val="10000"/>
+              </a:schemeClr>
+            </a:solidFill>
+          </a:ln>
+        </p:spPr>
+        <p:style>
+          <a:lnRef idx="2">
+            <a:schemeClr val="accent1">
+              <a:shade val="15000"/>
+            </a:schemeClr>
+          </a:lnRef>
+          <a:fillRef idx="1">
+            <a:schemeClr val="accent1"/>
+          </a:fillRef>
+          <a:effectRef idx="0">
+            <a:schemeClr val="accent1"/>
+          </a:effectRef>
+          <a:fontRef idx="minor">
+            <a:schemeClr val="lt1"/>
+          </a:fontRef>
+        </p:style>
+        <p:txBody>
+          <a:bodyPr rtlCol="0" anchor="ctr"/>
+          <a:lstStyle/>
+          <a:p>
+            <a:pPr algn="ctr"/>
+            <a:endParaRPr lang="zh-TW" altLang="en-US"/>
+          </a:p>
+        </p:txBody>
+      </p:sp>
+      <p:sp>
+        <p:nvSpPr>
+          <p:cNvPr id="9" name="矩形 8">
+            <a:extLst>
+              <a:ext uri="{FF2B5EF4-FFF2-40B4-BE49-F238E27FC236}">
+                <a16:creationId xmlns:a16="http://schemas.microsoft.com/office/drawing/2014/main" id="{C9776D49-E987-DCF6-AD46-5BB769235C9D}"/>
+              </a:ext>
+            </a:extLst>
+          </p:cNvPr>
+          <p:cNvSpPr/>
+          <p:nvPr/>
+        </p:nvSpPr>
+        <p:spPr>
+          <a:xfrm>
+            <a:off x="7391401" y="3082635"/>
+            <a:ext cx="671946" cy="1863437"/>
+          </a:xfrm>
+          <a:prstGeom prst="rect">
+            <a:avLst/>
+          </a:prstGeom>
+          <a:solidFill>
+            <a:srgbClr val="FF0000"/>
+          </a:solidFill>
+          <a:ln>
+            <a:solidFill>
+              <a:schemeClr val="tx2">
+                <a:lumMod val="90000"/>
+                <a:lumOff val="10000"/>
+              </a:schemeClr>
+            </a:solidFill>
+          </a:ln>
+        </p:spPr>
+        <p:style>
+          <a:lnRef idx="2">
+            <a:schemeClr val="accent1">
+              <a:shade val="15000"/>
+            </a:schemeClr>
+          </a:lnRef>
+          <a:fillRef idx="1">
+            <a:schemeClr val="accent1"/>
+          </a:fillRef>
+          <a:effectRef idx="0">
+            <a:schemeClr val="accent1"/>
+          </a:effectRef>
+          <a:fontRef idx="minor">
+            <a:schemeClr val="lt1"/>
+          </a:fontRef>
+        </p:style>
+        <p:txBody>
+          <a:bodyPr rtlCol="0" anchor="ctr"/>
+          <a:lstStyle/>
+          <a:p>
+            <a:pPr algn="ctr"/>
+            <a:endParaRPr lang="zh-TW" altLang="en-US" dirty="0">
+              <a:solidFill>
+                <a:schemeClr val="accent2">
+                  <a:lumMod val="50000"/>
+                </a:schemeClr>
+              </a:solidFill>
+            </a:endParaRPr>
+          </a:p>
+        </p:txBody>
+      </p:sp>
+      <p:pic>
+        <p:nvPicPr>
+          <p:cNvPr id="11" name="圖片 10">
+            <a:extLst>
+              <a:ext uri="{FF2B5EF4-FFF2-40B4-BE49-F238E27FC236}">
+                <a16:creationId xmlns:a16="http://schemas.microsoft.com/office/drawing/2014/main" id="{1217B257-B772-B604-42A9-75BA2A39C5DE}"/>
+              </a:ext>
+            </a:extLst>
+          </p:cNvPr>
+          <p:cNvPicPr>
+            <a:picLocks noChangeAspect="1"/>
+          </p:cNvPicPr>
+          <p:nvPr/>
+        </p:nvPicPr>
+        <p:blipFill>
+          <a:blip r:embed="rId2">
+            <a:extLst>
+              <a:ext uri="{28A0092B-C50C-407E-A947-70E740481C1C}">
+                <a14:useLocalDpi xmlns:a14="http://schemas.microsoft.com/office/drawing/2010/main" val="0"/>
+              </a:ext>
+            </a:extLst>
+          </a:blip>
+          <a:stretch>
+            <a:fillRect/>
+          </a:stretch>
+        </p:blipFill>
+        <p:spPr>
+          <a:xfrm>
+            <a:off x="1844390" y="3297382"/>
+            <a:ext cx="642501" cy="642501"/>
+          </a:xfrm>
+          <a:prstGeom prst="rect">
+            <a:avLst/>
+          </a:prstGeom>
+        </p:spPr>
+      </p:pic>
+      <p:sp>
+        <p:nvSpPr>
+          <p:cNvPr id="12" name="矩形 11">
+            <a:extLst>
+              <a:ext uri="{FF2B5EF4-FFF2-40B4-BE49-F238E27FC236}">
+                <a16:creationId xmlns:a16="http://schemas.microsoft.com/office/drawing/2014/main" id="{88352D55-6032-BE19-D36D-49856ABA5E84}"/>
+              </a:ext>
+            </a:extLst>
+          </p:cNvPr>
+          <p:cNvSpPr/>
+          <p:nvPr/>
+        </p:nvSpPr>
+        <p:spPr>
+          <a:xfrm>
+            <a:off x="3386571" y="3219450"/>
+            <a:ext cx="438150" cy="1726622"/>
+          </a:xfrm>
+          <a:prstGeom prst="rect">
+            <a:avLst/>
+          </a:prstGeom>
+        </p:spPr>
+        <p:style>
+          <a:lnRef idx="2">
+            <a:schemeClr val="accent1">
+              <a:shade val="15000"/>
+            </a:schemeClr>
+          </a:lnRef>
+          <a:fillRef idx="1">
+            <a:schemeClr val="accent1"/>
+          </a:fillRef>
+          <a:effectRef idx="0">
+            <a:schemeClr val="accent1"/>
+          </a:effectRef>
+          <a:fontRef idx="minor">
+            <a:schemeClr val="lt1"/>
+          </a:fontRef>
+        </p:style>
+        <p:txBody>
+          <a:bodyPr rtlCol="0" anchor="ctr"/>
+          <a:lstStyle/>
+          <a:p>
+            <a:pPr algn="ctr"/>
+            <a:endParaRPr lang="zh-TW" altLang="en-US"/>
+          </a:p>
+        </p:txBody>
+      </p:sp>
+      <p:sp>
+        <p:nvSpPr>
+          <p:cNvPr id="13" name="矩形 12">
+            <a:extLst>
+              <a:ext uri="{FF2B5EF4-FFF2-40B4-BE49-F238E27FC236}">
+                <a16:creationId xmlns:a16="http://schemas.microsoft.com/office/drawing/2014/main" id="{0BA76651-BE66-71C7-EB0C-CA3A2CBEC754}"/>
+              </a:ext>
+            </a:extLst>
+          </p:cNvPr>
+          <p:cNvSpPr/>
+          <p:nvPr/>
+        </p:nvSpPr>
+        <p:spPr>
+          <a:xfrm>
+            <a:off x="7508299" y="3219450"/>
+            <a:ext cx="438150" cy="1726622"/>
+          </a:xfrm>
+          <a:prstGeom prst="rect">
+            <a:avLst/>
+          </a:prstGeom>
+          <a:solidFill>
+            <a:srgbClr val="C00000"/>
+          </a:solidFill>
+        </p:spPr>
+        <p:style>
+          <a:lnRef idx="2">
+            <a:schemeClr val="accent1">
+              <a:shade val="15000"/>
+            </a:schemeClr>
+          </a:lnRef>
+          <a:fillRef idx="1">
+            <a:schemeClr val="accent1"/>
+          </a:fillRef>
+          <a:effectRef idx="0">
+            <a:schemeClr val="accent1"/>
+          </a:effectRef>
+          <a:fontRef idx="minor">
+            <a:schemeClr val="lt1"/>
+          </a:fontRef>
+        </p:style>
+        <p:txBody>
+          <a:bodyPr rtlCol="0" anchor="ctr"/>
+          <a:lstStyle/>
+          <a:p>
+            <a:pPr algn="ctr"/>
+            <a:endParaRPr lang="zh-TW" altLang="en-US"/>
+          </a:p>
+        </p:txBody>
+      </p:sp>
+      <p:pic>
+        <p:nvPicPr>
+          <p:cNvPr id="17" name="圖片 16">
+            <a:extLst>
+              <a:ext uri="{FF2B5EF4-FFF2-40B4-BE49-F238E27FC236}">
+                <a16:creationId xmlns:a16="http://schemas.microsoft.com/office/drawing/2014/main" id="{EF150F27-F130-CDA1-1EDE-59646147A2BD}"/>
+              </a:ext>
+            </a:extLst>
+          </p:cNvPr>
+          <p:cNvPicPr>
+            <a:picLocks noChangeAspect="1"/>
+          </p:cNvPicPr>
+          <p:nvPr/>
+        </p:nvPicPr>
+        <p:blipFill>
+          <a:blip r:embed="rId3">
+            <a:extLst>
+              <a:ext uri="{28A0092B-C50C-407E-A947-70E740481C1C}">
+                <a14:useLocalDpi xmlns:a14="http://schemas.microsoft.com/office/drawing/2010/main" val="0"/>
+              </a:ext>
+            </a:extLst>
+          </a:blip>
+          <a:stretch>
+            <a:fillRect/>
+          </a:stretch>
+        </p:blipFill>
+        <p:spPr>
+          <a:xfrm>
+            <a:off x="5581074" y="3197223"/>
+            <a:ext cx="842817" cy="842817"/>
+          </a:xfrm>
+          <a:prstGeom prst="rect">
+            <a:avLst/>
+          </a:prstGeom>
+        </p:spPr>
+      </p:pic>
+    </p:spTree>
+    <p:extLst>
+      <p:ext uri="{BB962C8B-B14F-4D97-AF65-F5344CB8AC3E}">
+        <p14:creationId xmlns:p14="http://schemas.microsoft.com/office/powerpoint/2010/main" val="3171473195"/>
+      </p:ext>
+    </p:extLst>
+  </p:cSld>
+  <p:clrMapOvr>
+    <a:masterClrMapping/>
+  </p:clrMapOvr>
+</p:sld>
+</file>
+
+<file path=ppt/slides/slide3.xml><?xml version="1.0" encoding="utf-8"?>
 <p:sld xmlns:a="http://schemas.openxmlformats.org/drawingml/2006/main" xmlns:r="http://schemas.openxmlformats.org/officeDocument/2006/relationships" xmlns:p="http://schemas.openxmlformats.org/presentationml/2006/main">
   <p:cSld>
     <p:spTree>

</xml_diff>